<commit_message>
Lecture 7: remove premature Casanovo name-drops (introduced in L8, not before)
</commit_message>
<xml_diff>
--- a/slides/pptx/lecture07_attention.pptx
+++ b/slides/pptx/lecture07_attention.pptx
@@ -1513,7 +1513,7 @@
           <a:lstStyle/>
           <a:p>
             <a:r>
-              <a:t>First step for any sequence model: cut the input into TOKENS from a fixed vocabulary and give each an integer ID. For text the tokens are (roughly) words; for a peptide the natural tokens are amino acids — ACDEFG becomes six tokens A,C,D,E,F,G with IDs 1–6. The analogy to carry all hour: a peptide is a sentence and amino acids are its words. The 💬 pair prompt is a genuine hands-on beat (rule 8): tokenizing ACDEFG is trivial, but the real question is what the vocabulary should be once you allow modifications — the clean answer is that each modified residue simply gets its OWN token ID (phospho-S is a different "word" than S), which is exactly how protein language models like ESM handle it and how Casanovo (Lecture 8/Lab 3) treats residues. Harvest two or three vocabularies; there is no single right answer.</a:t>
+              <a:t>First step for any sequence model: cut the input into TOKENS from a fixed vocabulary and give each an integer ID. For text the tokens are (roughly) words; for a peptide the natural tokens are amino acids — ACDEFG becomes six tokens A,C,D,E,F,G with IDs 1–6. The analogy to carry all hour: a peptide is a sentence and amino acids are its words. The 💬 pair prompt is a genuine hands-on beat (rule 8): tokenizing ACDEFG is trivial, but the real question is what the vocabulary should be once you allow modifications — the clean answer is that each modified residue simply gets its OWN token ID (phospho-S is a different "word" than S), which is exactly how protein language models like ESM handle it, and how the peptide-sequencing transformers we build in Lecture 8 treat residues. Harvest two or three vocabularies; there is no single right answer.</a:t>
             </a:r>
           </a:p>
           <a:p/>
@@ -6961,7 +6961,7 @@
                 </a:solidFill>
                 <a:latin typeface="Avenir Next"/>
               </a:rPr>
-              <a:t>How a spectrum becomes tokens — patch it, CNN-encode it, or peak-as-token (Casanovo)</a:t>
+              <a:t>How a spectrum becomes tokens — patch it, CNN-encode it, or peak-as-token</a:t>
             </a:r>
           </a:p>
           <a:p>

</xml_diff>

<commit_message>
no-mistakes(review): restore borrowed slide images, fix credits, drop dead figures
</commit_message>
<xml_diff>
--- a/slides/pptx/lecture07_attention.pptx
+++ b/slides/pptx/lecture07_attention.pptx
@@ -3094,6 +3094,38 @@
           </a:p>
         </p:txBody>
       </p:sp>
+      <p:pic>
+        <p:nvPicPr>
+          <p:cNvPr id="5" name="Content Placeholder 4">
+            <a:extLst>
+              <a:ext uri="{FF2B5EF4-FFF2-40B4-BE49-F238E27FC236}">
+                <a16:creationId xmlns:a16="http://schemas.microsoft.com/office/drawing/2014/main" id="{EA00C68C-D623-1CAB-1513-81677C0118DF}"/>
+              </a:ext>
+            </a:extLst>
+          </p:cNvPr>
+          <p:cNvPicPr>
+            <a:picLocks noGrp="1" noChangeAspect="1"/>
+          </p:cNvPicPr>
+          <p:nvPr>
+            <p:ph idx="1"/>
+          </p:nvPr>
+        </p:nvPicPr>
+        <p:blipFill>
+          <a:blip r:embed="rId2"/>
+          <a:stretch>
+            <a:fillRect/>
+          </a:stretch>
+        </p:blipFill>
+        <p:spPr>
+          <a:xfrm>
+            <a:off x="1552446" y="1615440"/>
+            <a:ext cx="7793988" cy="4922519"/>
+          </a:xfrm>
+          <a:prstGeom prst="rect">
+            <a:avLst/>
+          </a:prstGeom>
+        </p:spPr>
+      </p:pic>
       <p:sp>
         <p:nvSpPr>
           <p:cNvPr id="4" name="Text Placeholder 3">
@@ -3122,39 +3154,171 @@
           </a:p>
         </p:txBody>
       </p:sp>
-      <p:pic>
-        <p:nvPicPr>
-          <p:cNvPr id="15" name="Picture 14" descr="fig_qkv_projection.png"/>
-          <p:cNvPicPr>
-            <a:picLocks noChangeAspect="1"/>
-          </p:cNvPicPr>
-          <p:nvPr/>
-        </p:nvPicPr>
-        <p:blipFill>
-          <a:blip r:embed="rId3"/>
-          <a:stretch>
-            <a:fillRect/>
-          </a:stretch>
-        </p:blipFill>
-        <p:spPr>
-          <a:xfrm>
-            <a:off x="1722928" y="1828800"/>
-            <a:ext cx="8745837" cy="4160520"/>
-          </a:xfrm>
-          <a:prstGeom prst="rect">
-            <a:avLst/>
-          </a:prstGeom>
-        </p:spPr>
-      </p:pic>
-      <p:sp>
-        <p:nvSpPr>
-          <p:cNvPr id="16" name="TextBox 15"/>
+      <p:sp>
+        <p:nvSpPr>
+          <p:cNvPr id="6" name="Rounded Rectangle 5">
+            <a:extLst>
+              <a:ext uri="{FF2B5EF4-FFF2-40B4-BE49-F238E27FC236}">
+                <a16:creationId xmlns:a16="http://schemas.microsoft.com/office/drawing/2014/main" id="{084DC98F-3671-8BEB-2CD1-A44C4777665B}"/>
+              </a:ext>
+            </a:extLst>
+          </p:cNvPr>
+          <p:cNvSpPr/>
+          <p:nvPr/>
+        </p:nvSpPr>
+        <p:spPr>
+          <a:xfrm>
+            <a:off x="7525265" y="2570205"/>
+            <a:ext cx="1865870" cy="1210963"/>
+          </a:xfrm>
+          <a:prstGeom prst="roundRect">
+            <a:avLst/>
+          </a:prstGeom>
+          <a:noFill/>
+          <a:ln w="28575">
+            <a:solidFill>
+              <a:srgbClr val="FF0000"/>
+            </a:solidFill>
+          </a:ln>
+        </p:spPr>
+        <p:style>
+          <a:lnRef idx="1">
+            <a:schemeClr val="accent1"/>
+          </a:lnRef>
+          <a:fillRef idx="3">
+            <a:schemeClr val="accent1"/>
+          </a:fillRef>
+          <a:effectRef idx="2">
+            <a:schemeClr val="accent1"/>
+          </a:effectRef>
+          <a:fontRef idx="minor">
+            <a:schemeClr val="lt1"/>
+          </a:fontRef>
+        </p:style>
+        <p:txBody>
+          <a:bodyPr rtlCol="0" anchor="ctr"/>
+          <a:lstStyle/>
+          <a:p>
+            <a:pPr algn="ctr"/>
+            <a:endParaRPr lang="en-US"/>
+          </a:p>
+        </p:txBody>
+      </p:sp>
+      <p:sp>
+        <p:nvSpPr>
+          <p:cNvPr id="7" name="Rounded Rectangle 6">
+            <a:extLst>
+              <a:ext uri="{FF2B5EF4-FFF2-40B4-BE49-F238E27FC236}">
+                <a16:creationId xmlns:a16="http://schemas.microsoft.com/office/drawing/2014/main" id="{FB7CD2EB-C228-A35E-6AF6-0A398EA29A2E}"/>
+              </a:ext>
+            </a:extLst>
+          </p:cNvPr>
+          <p:cNvSpPr/>
+          <p:nvPr/>
+        </p:nvSpPr>
+        <p:spPr>
+          <a:xfrm>
+            <a:off x="7525265" y="3948600"/>
+            <a:ext cx="1865870" cy="1210963"/>
+          </a:xfrm>
+          <a:prstGeom prst="roundRect">
+            <a:avLst/>
+          </a:prstGeom>
+          <a:noFill/>
+          <a:ln w="28575">
+            <a:solidFill>
+              <a:srgbClr val="FF0000"/>
+            </a:solidFill>
+          </a:ln>
+        </p:spPr>
+        <p:style>
+          <a:lnRef idx="1">
+            <a:schemeClr val="accent1"/>
+          </a:lnRef>
+          <a:fillRef idx="3">
+            <a:schemeClr val="accent1"/>
+          </a:fillRef>
+          <a:effectRef idx="2">
+            <a:schemeClr val="accent1"/>
+          </a:effectRef>
+          <a:fontRef idx="minor">
+            <a:schemeClr val="lt1"/>
+          </a:fontRef>
+        </p:style>
+        <p:txBody>
+          <a:bodyPr rtlCol="0" anchor="ctr"/>
+          <a:lstStyle/>
+          <a:p>
+            <a:pPr algn="ctr"/>
+            <a:endParaRPr lang="en-US"/>
+          </a:p>
+        </p:txBody>
+      </p:sp>
+      <p:sp>
+        <p:nvSpPr>
+          <p:cNvPr id="8" name="Rounded Rectangle 7">
+            <a:extLst>
+              <a:ext uri="{FF2B5EF4-FFF2-40B4-BE49-F238E27FC236}">
+                <a16:creationId xmlns:a16="http://schemas.microsoft.com/office/drawing/2014/main" id="{575A6296-8F29-06E8-32D9-4E1727FE3DD0}"/>
+              </a:ext>
+            </a:extLst>
+          </p:cNvPr>
+          <p:cNvSpPr/>
+          <p:nvPr/>
+        </p:nvSpPr>
+        <p:spPr>
+          <a:xfrm>
+            <a:off x="7525265" y="5326996"/>
+            <a:ext cx="1865870" cy="1210963"/>
+          </a:xfrm>
+          <a:prstGeom prst="roundRect">
+            <a:avLst/>
+          </a:prstGeom>
+          <a:noFill/>
+          <a:ln w="28575">
+            <a:solidFill>
+              <a:srgbClr val="FF0000"/>
+            </a:solidFill>
+          </a:ln>
+        </p:spPr>
+        <p:style>
+          <a:lnRef idx="1">
+            <a:schemeClr val="accent1"/>
+          </a:lnRef>
+          <a:fillRef idx="3">
+            <a:schemeClr val="accent1"/>
+          </a:fillRef>
+          <a:effectRef idx="2">
+            <a:schemeClr val="accent1"/>
+          </a:effectRef>
+          <a:fontRef idx="minor">
+            <a:schemeClr val="lt1"/>
+          </a:fontRef>
+        </p:style>
+        <p:txBody>
+          <a:bodyPr rtlCol="0" anchor="ctr"/>
+          <a:lstStyle/>
+          <a:p>
+            <a:pPr algn="ctr"/>
+            <a:endParaRPr lang="en-US"/>
+          </a:p>
+        </p:txBody>
+      </p:sp>
+      <p:sp>
+        <p:nvSpPr>
+          <p:cNvPr id="9" name="TextBox 8">
+            <a:extLst>
+              <a:ext uri="{FF2B5EF4-FFF2-40B4-BE49-F238E27FC236}">
+                <a16:creationId xmlns:a16="http://schemas.microsoft.com/office/drawing/2014/main" id="{463080A5-9E0D-CEFE-281E-E686B35E719C}"/>
+              </a:ext>
+            </a:extLst>
+          </p:cNvPr>
           <p:cNvSpPr txBox="1"/>
           <p:nvPr/>
         </p:nvSpPr>
         <p:spPr>
           <a:xfrm>
-            <a:off x="548640" y="6144768"/>
+            <a:off x="548640" y="6455664"/>
             <a:ext cx="11091672" cy="310896"/>
           </a:xfrm>
           <a:prstGeom prst="rect">
@@ -3163,20 +3327,20 @@
           <a:noFill/>
         </p:spPr>
         <p:txBody>
-          <a:bodyPr wrap="square">
+          <a:bodyPr wrap="none" rtlCol="0">
             <a:spAutoFit/>
           </a:bodyPr>
           <a:lstStyle/>
           <a:p>
-            <a:pPr algn="ctr"/>
-            <a:r>
-              <a:rPr sz="1100">
-                <a:solidFill>
-                  <a:srgbClr val="8A9099"/>
-                </a:solidFill>
-                <a:latin typeface="Menlo"/>
-              </a:rPr>
-              <a:t>Course-drawn figure for MSACL DS301 · mechanism after Vaswani et al., NeurIPS 2017 (arXiv:1706.03762)</a:t>
+            <a:r>
+              <a:rPr lang="en-US" sz="1100" i="1" dirty="0">
+                <a:solidFill>
+                  <a:schemeClr val="accent6">
+                    <a:lumMod val="75000"/>
+                  </a:schemeClr>
+                </a:solidFill>
+              </a:rPr>
+              <a:t>source: Jay Alammar, “The Illustrated Transformer” — jalammar.github.io/illustrated-transformer/</a:t>
             </a:r>
           </a:p>
         </p:txBody>

</xml_diff>